<commit_message>
docs: PPT v4 - slide 4 uses real game screenshot; repo link only (no commit records)
</commit_message>
<xml_diff>
--- a/docs/斗地组_课堂展示PPT.pptx
+++ b/docs/斗地组_课堂展示PPT.pptx
@@ -791,7 +791,7 @@
           <a:lstStyle/>
           <a:p>
             <a:r>
-              <a:t>给大家看一下实际运行效果。终端里每一帧显示：本房间地图、信息区、小地图和状态栏。所有交互都是输入命令，中文英文都行，比如“去 东”或 go east、“攻击 哥布林”或 attack goblin、“拾取”或 pick。</a:t>
+              <a:t>给大家看一下实际运行效果截图。每一帧显示：本房间地图、信息区、小地图和状态栏，节点颜色即语义（@蓝色=你、B红色=魔王、F/T/&amp;#36;/S/&amp;gt;为各房间属性）。所有交互都是输入命令，中文英文都行，比如“去 东”或 go east、“攻击 哥布林”或 attack goblin。</a:t>
             </a:r>
           </a:p>
         </p:txBody>
@@ -7140,27 +7140,49 @@
           </a:p>
         </p:txBody>
       </p:sp>
-      <p:sp>
-        <p:nvSpPr>
-          <p:cNvPr id="6" name="Rounded Rectangle 5"/>
+      <p:pic>
+        <p:nvPicPr>
+          <p:cNvPr id="6" name="Picture 5" descr="游戏截图.png"/>
+          <p:cNvPicPr>
+            <a:picLocks noChangeAspect="1"/>
+          </p:cNvPicPr>
+          <p:nvPr/>
+        </p:nvPicPr>
+        <p:blipFill>
+          <a:blip r:embed="rId2"/>
+          <a:stretch>
+            <a:fillRect/>
+          </a:stretch>
+        </p:blipFill>
+        <p:spPr>
+          <a:xfrm>
+            <a:off x="640080" y="1234440"/>
+            <a:ext cx="3794760" cy="4855464"/>
+          </a:xfrm>
+          <a:prstGeom prst="rect">
+            <a:avLst/>
+          </a:prstGeom>
+        </p:spPr>
+      </p:pic>
+      <p:sp>
+        <p:nvSpPr>
+          <p:cNvPr id="7" name="Rectangle 6"/>
           <p:cNvSpPr/>
           <p:nvPr/>
         </p:nvSpPr>
         <p:spPr>
           <a:xfrm>
             <a:off x="640080" y="1234440"/>
-            <a:ext cx="5669280" cy="4846320"/>
-          </a:xfrm>
-          <a:prstGeom prst="roundRect">
-            <a:avLst>
-              <a:gd name="adj" fmla="val 8000"/>
-            </a:avLst>
-          </a:prstGeom>
-          <a:solidFill>
-            <a:srgbClr val="111824"/>
-          </a:solidFill>
-          <a:ln>
-            <a:noFill/>
+            <a:ext cx="3794760" cy="4855464"/>
+          </a:xfrm>
+          <a:prstGeom prst="rect">
+            <a:avLst/>
+          </a:prstGeom>
+          <a:noFill/>
+          <a:ln w="19050">
+            <a:solidFill>
+              <a:srgbClr val="003366"/>
+            </a:solidFill>
           </a:ln>
         </p:spPr>
         <p:style>
@@ -7187,443 +7209,14 @@
       </p:sp>
       <p:sp>
         <p:nvSpPr>
-          <p:cNvPr id="7" name="TextBox 6"/>
-          <p:cNvSpPr txBox="1"/>
-          <p:nvPr/>
-        </p:nvSpPr>
-        <p:spPr>
-          <a:xfrm>
-            <a:off x="914400" y="1508760"/>
-            <a:ext cx="5212080" cy="365760"/>
-          </a:xfrm>
-          <a:prstGeom prst="rect">
-            <a:avLst/>
-          </a:prstGeom>
-          <a:noFill/>
-        </p:spPr>
-        <p:txBody>
-          <a:bodyPr wrap="square" anchor="t">
-            <a:spAutoFit/>
-          </a:bodyPr>
-          <a:lstStyle/>
-          <a:p>
-            <a:pPr algn="l">
-              <a:lnSpc>
-                <a:spcPct val="100000"/>
-              </a:lnSpc>
-            </a:pPr>
-            <a:r>
-              <a:rPr sz="1300" b="0">
-                <a:solidFill>
-                  <a:srgbClr val="2ECC71"/>
-                </a:solidFill>
-                <a:latin typeface="Consolas"/>
-              </a:rPr>
-              <a:t>$ ./mud_text 42</a:t>
-            </a:r>
-          </a:p>
-        </p:txBody>
-      </p:sp>
-      <p:sp>
-        <p:nvSpPr>
-          <p:cNvPr id="8" name="TextBox 7"/>
-          <p:cNvSpPr txBox="1"/>
-          <p:nvPr/>
-        </p:nvSpPr>
-        <p:spPr>
-          <a:xfrm>
-            <a:off x="914400" y="1892807"/>
-            <a:ext cx="5212080" cy="365760"/>
-          </a:xfrm>
-          <a:prstGeom prst="rect">
-            <a:avLst/>
-          </a:prstGeom>
-          <a:noFill/>
-        </p:spPr>
-        <p:txBody>
-          <a:bodyPr wrap="square" anchor="t">
-            <a:spAutoFit/>
-          </a:bodyPr>
-          <a:lstStyle/>
-          <a:p>
-            <a:pPr algn="l">
-              <a:lnSpc>
-                <a:spcPct val="100000"/>
-              </a:lnSpc>
-            </a:pPr>
-            <a:r>
-              <a:rPr sz="1300" b="0">
-                <a:solidFill>
-                  <a:srgbClr val="F4D03F"/>
-                </a:solidFill>
-                <a:latin typeface="Consolas"/>
-              </a:rPr>
-              <a:t>【起点房】你站在地牢入口…</a:t>
-            </a:r>
-          </a:p>
-        </p:txBody>
-      </p:sp>
-      <p:sp>
-        <p:nvSpPr>
-          <p:cNvPr id="9" name="TextBox 8"/>
-          <p:cNvSpPr txBox="1"/>
-          <p:nvPr/>
-        </p:nvSpPr>
-        <p:spPr>
-          <a:xfrm>
-            <a:off x="914400" y="2276856"/>
-            <a:ext cx="5212080" cy="365760"/>
-          </a:xfrm>
-          <a:prstGeom prst="rect">
-            <a:avLst/>
-          </a:prstGeom>
-          <a:noFill/>
-        </p:spPr>
-        <p:txBody>
-          <a:bodyPr wrap="square" anchor="t">
-            <a:spAutoFit/>
-          </a:bodyPr>
-          <a:lstStyle/>
-          <a:p>
-            <a:pPr algn="l">
-              <a:lnSpc>
-                <a:spcPct val="100000"/>
-              </a:lnSpc>
-            </a:pPr>
-            <a:r>
-              <a:rPr sz="1300" b="0">
-                <a:solidFill>
-                  <a:srgbClr val="5DADE2"/>
-                </a:solidFill>
-                <a:latin typeface="Consolas"/>
-              </a:rPr>
-              <a:t>小地图： [@]  ###  [ ]</a:t>
-            </a:r>
-          </a:p>
-        </p:txBody>
-      </p:sp>
-      <p:sp>
-        <p:nvSpPr>
-          <p:cNvPr id="10" name="TextBox 9"/>
-          <p:cNvSpPr txBox="1"/>
-          <p:nvPr/>
-        </p:nvSpPr>
-        <p:spPr>
-          <a:xfrm>
-            <a:off x="914400" y="3044951"/>
-            <a:ext cx="5212080" cy="365760"/>
-          </a:xfrm>
-          <a:prstGeom prst="rect">
-            <a:avLst/>
-          </a:prstGeom>
-          <a:noFill/>
-        </p:spPr>
-        <p:txBody>
-          <a:bodyPr wrap="square" anchor="t">
-            <a:spAutoFit/>
-          </a:bodyPr>
-          <a:lstStyle/>
-          <a:p>
-            <a:pPr algn="l">
-              <a:lnSpc>
-                <a:spcPct val="100000"/>
-              </a:lnSpc>
-            </a:pPr>
-            <a:r>
-              <a:rPr sz="1300" b="0">
-                <a:solidFill>
-                  <a:srgbClr val="FFFFFF"/>
-                </a:solidFill>
-                <a:latin typeface="Consolas"/>
-              </a:rPr>
-              <a:t>&gt; 去 东</a:t>
-            </a:r>
-          </a:p>
-        </p:txBody>
-      </p:sp>
-      <p:sp>
-        <p:nvSpPr>
-          <p:cNvPr id="11" name="TextBox 10"/>
-          <p:cNvSpPr txBox="1"/>
-          <p:nvPr/>
-        </p:nvSpPr>
-        <p:spPr>
-          <a:xfrm>
-            <a:off x="914400" y="3428999"/>
-            <a:ext cx="5212080" cy="365760"/>
-          </a:xfrm>
-          <a:prstGeom prst="rect">
-            <a:avLst/>
-          </a:prstGeom>
-          <a:noFill/>
-        </p:spPr>
-        <p:txBody>
-          <a:bodyPr wrap="square" anchor="t">
-            <a:spAutoFit/>
-          </a:bodyPr>
-          <a:lstStyle/>
-          <a:p>
-            <a:pPr algn="l">
-              <a:lnSpc>
-                <a:spcPct val="100000"/>
-              </a:lnSpc>
-            </a:pPr>
-            <a:r>
-              <a:rPr sz="1300" b="0">
-                <a:solidFill>
-                  <a:srgbClr val="F4D03F"/>
-                </a:solidFill>
-                <a:latin typeface="Consolas"/>
-              </a:rPr>
-              <a:t>【战斗房】哥布林 出现了！</a:t>
-            </a:r>
-          </a:p>
-        </p:txBody>
-      </p:sp>
-      <p:sp>
-        <p:nvSpPr>
-          <p:cNvPr id="12" name="TextBox 11"/>
-          <p:cNvSpPr txBox="1"/>
-          <p:nvPr/>
-        </p:nvSpPr>
-        <p:spPr>
-          <a:xfrm>
-            <a:off x="914400" y="3813048"/>
-            <a:ext cx="5212080" cy="365760"/>
-          </a:xfrm>
-          <a:prstGeom prst="rect">
-            <a:avLst/>
-          </a:prstGeom>
-          <a:noFill/>
-        </p:spPr>
-        <p:txBody>
-          <a:bodyPr wrap="square" anchor="t">
-            <a:spAutoFit/>
-          </a:bodyPr>
-          <a:lstStyle/>
-          <a:p>
-            <a:pPr algn="l">
-              <a:lnSpc>
-                <a:spcPct val="100000"/>
-              </a:lnSpc>
-            </a:pPr>
-            <a:r>
-              <a:rPr sz="1300" b="0">
-                <a:solidFill>
-                  <a:srgbClr val="E67E22"/>
-                </a:solidFill>
-                <a:latin typeface="Consolas"/>
-              </a:rPr>
-              <a:t>(哥布林 HP 12/12)</a:t>
-            </a:r>
-          </a:p>
-        </p:txBody>
-      </p:sp>
-      <p:sp>
-        <p:nvSpPr>
-          <p:cNvPr id="13" name="TextBox 12"/>
-          <p:cNvSpPr txBox="1"/>
-          <p:nvPr/>
-        </p:nvSpPr>
-        <p:spPr>
-          <a:xfrm>
-            <a:off x="914400" y="4197096"/>
-            <a:ext cx="5212080" cy="365760"/>
-          </a:xfrm>
-          <a:prstGeom prst="rect">
-            <a:avLst/>
-          </a:prstGeom>
-          <a:noFill/>
-        </p:spPr>
-        <p:txBody>
-          <a:bodyPr wrap="square" anchor="t">
-            <a:spAutoFit/>
-          </a:bodyPr>
-          <a:lstStyle/>
-          <a:p>
-            <a:pPr algn="l">
-              <a:lnSpc>
-                <a:spcPct val="100000"/>
-              </a:lnSpc>
-            </a:pPr>
-            <a:r>
-              <a:rPr sz="1300" b="0">
-                <a:solidFill>
-                  <a:srgbClr val="FFFFFF"/>
-                </a:solidFill>
-                <a:latin typeface="Consolas"/>
-              </a:rPr>
-              <a:t>&gt; 攻击 哥布林</a:t>
-            </a:r>
-          </a:p>
-        </p:txBody>
-      </p:sp>
-      <p:sp>
-        <p:nvSpPr>
-          <p:cNvPr id="14" name="TextBox 13"/>
-          <p:cNvSpPr txBox="1"/>
-          <p:nvPr/>
-        </p:nvSpPr>
-        <p:spPr>
-          <a:xfrm>
-            <a:off x="914400" y="4581144"/>
-            <a:ext cx="5212080" cy="365760"/>
-          </a:xfrm>
-          <a:prstGeom prst="rect">
-            <a:avLst/>
-          </a:prstGeom>
-          <a:noFill/>
-        </p:spPr>
-        <p:txBody>
-          <a:bodyPr wrap="square" anchor="t">
-            <a:spAutoFit/>
-          </a:bodyPr>
-          <a:lstStyle/>
-          <a:p>
-            <a:pPr algn="l">
-              <a:lnSpc>
-                <a:spcPct val="100000"/>
-              </a:lnSpc>
-            </a:pPr>
-            <a:r>
-              <a:rPr sz="1300" b="0">
-                <a:solidFill>
-                  <a:srgbClr val="2ECC71"/>
-                </a:solidFill>
-                <a:latin typeface="Consolas"/>
-              </a:rPr>
-              <a:t>你对 哥布林 造成 5 点伤害</a:t>
-            </a:r>
-          </a:p>
-        </p:txBody>
-      </p:sp>
-      <p:sp>
-        <p:nvSpPr>
-          <p:cNvPr id="15" name="TextBox 14"/>
-          <p:cNvSpPr txBox="1"/>
-          <p:nvPr/>
-        </p:nvSpPr>
-        <p:spPr>
-          <a:xfrm>
-            <a:off x="914400" y="4965192"/>
-            <a:ext cx="5212080" cy="365760"/>
-          </a:xfrm>
-          <a:prstGeom prst="rect">
-            <a:avLst/>
-          </a:prstGeom>
-          <a:noFill/>
-        </p:spPr>
-        <p:txBody>
-          <a:bodyPr wrap="square" anchor="t">
-            <a:spAutoFit/>
-          </a:bodyPr>
-          <a:lstStyle/>
-          <a:p>
-            <a:pPr algn="l">
-              <a:lnSpc>
-                <a:spcPct val="100000"/>
-              </a:lnSpc>
-            </a:pPr>
-            <a:r>
-              <a:rPr sz="1300" b="0">
-                <a:solidFill>
-                  <a:srgbClr val="E67E22"/>
-                </a:solidFill>
-                <a:latin typeface="Consolas"/>
-              </a:rPr>
-              <a:t>(哥布林 HP 7/12) → 反击 -3</a:t>
-            </a:r>
-          </a:p>
-        </p:txBody>
-      </p:sp>
-      <p:sp>
-        <p:nvSpPr>
-          <p:cNvPr id="16" name="TextBox 15"/>
-          <p:cNvSpPr txBox="1"/>
-          <p:nvPr/>
-        </p:nvSpPr>
-        <p:spPr>
-          <a:xfrm>
-            <a:off x="914400" y="5349240"/>
-            <a:ext cx="5212080" cy="365760"/>
-          </a:xfrm>
-          <a:prstGeom prst="rect">
-            <a:avLst/>
-          </a:prstGeom>
-          <a:noFill/>
-        </p:spPr>
-        <p:txBody>
-          <a:bodyPr wrap="square" anchor="t">
-            <a:spAutoFit/>
-          </a:bodyPr>
-          <a:lstStyle/>
-          <a:p>
-            <a:pPr algn="l">
-              <a:lnSpc>
-                <a:spcPct val="100000"/>
-              </a:lnSpc>
-            </a:pPr>
-            <a:r>
-              <a:rPr sz="1300" b="0">
-                <a:solidFill>
-                  <a:srgbClr val="FFFFFF"/>
-                </a:solidFill>
-                <a:latin typeface="Consolas"/>
-              </a:rPr>
-              <a:t>&gt; 拾取</a:t>
-            </a:r>
-          </a:p>
-        </p:txBody>
-      </p:sp>
-      <p:sp>
-        <p:nvSpPr>
-          <p:cNvPr id="17" name="TextBox 16"/>
-          <p:cNvSpPr txBox="1"/>
-          <p:nvPr/>
-        </p:nvSpPr>
-        <p:spPr>
-          <a:xfrm>
-            <a:off x="914400" y="5733288"/>
-            <a:ext cx="5212080" cy="365760"/>
-          </a:xfrm>
-          <a:prstGeom prst="rect">
-            <a:avLst/>
-          </a:prstGeom>
-          <a:noFill/>
-        </p:spPr>
-        <p:txBody>
-          <a:bodyPr wrap="square" anchor="t">
-            <a:spAutoFit/>
-          </a:bodyPr>
-          <a:lstStyle/>
-          <a:p>
-            <a:pPr algn="l">
-              <a:lnSpc>
-                <a:spcPct val="100000"/>
-              </a:lnSpc>
-            </a:pPr>
-            <a:r>
-              <a:rPr sz="1300" b="0">
-                <a:solidFill>
-                  <a:srgbClr val="F1C40F"/>
-                </a:solidFill>
-                <a:latin typeface="Consolas"/>
-              </a:rPr>
-              <a:t>获得 铁剑（攻+2）</a:t>
-            </a:r>
-          </a:p>
-        </p:txBody>
-      </p:sp>
-      <p:sp>
-        <p:nvSpPr>
-          <p:cNvPr id="18" name="Rounded Rectangle 17"/>
+          <p:cNvPr id="8" name="Rounded Rectangle 7"/>
           <p:cNvSpPr/>
           <p:nvPr/>
         </p:nvSpPr>
         <p:spPr>
           <a:xfrm>
-            <a:off x="6583680" y="1234440"/>
-            <a:ext cx="4937760" cy="4846320"/>
+            <a:off x="4709160" y="1234440"/>
+            <a:ext cx="6812280" cy="4846320"/>
           </a:xfrm>
           <a:prstGeom prst="roundRect">
             <a:avLst>
@@ -7661,14 +7254,14 @@
       </p:sp>
       <p:sp>
         <p:nvSpPr>
-          <p:cNvPr id="19" name="TextBox 18"/>
+          <p:cNvPr id="9" name="TextBox 8"/>
           <p:cNvSpPr txBox="1"/>
           <p:nvPr/>
         </p:nvSpPr>
         <p:spPr>
           <a:xfrm>
-            <a:off x="6858000" y="1463040"/>
-            <a:ext cx="4480560" cy="457200"/>
+            <a:off x="4983480" y="1463040"/>
+            <a:ext cx="6309360" cy="457200"/>
           </a:xfrm>
           <a:prstGeom prst="rect">
             <a:avLst/>
@@ -7700,14 +7293,14 @@
       </p:sp>
       <p:sp>
         <p:nvSpPr>
-          <p:cNvPr id="20" name="TextBox 19"/>
+          <p:cNvPr id="10" name="TextBox 9"/>
           <p:cNvSpPr txBox="1"/>
           <p:nvPr/>
         </p:nvSpPr>
         <p:spPr>
           <a:xfrm>
-            <a:off x="6858000" y="2011680"/>
-            <a:ext cx="4480560" cy="365760"/>
+            <a:off x="4983480" y="2011680"/>
+            <a:ext cx="6309360" cy="365760"/>
           </a:xfrm>
           <a:prstGeom prst="rect">
             <a:avLst/>
@@ -7739,14 +7332,14 @@
       </p:sp>
       <p:sp>
         <p:nvSpPr>
-          <p:cNvPr id="21" name="TextBox 20"/>
+          <p:cNvPr id="11" name="TextBox 10"/>
           <p:cNvSpPr txBox="1"/>
           <p:nvPr/>
         </p:nvSpPr>
         <p:spPr>
           <a:xfrm>
-            <a:off x="6858000" y="2441448"/>
-            <a:ext cx="4480560" cy="365760"/>
+            <a:off x="4983480" y="2441448"/>
+            <a:ext cx="6309360" cy="365760"/>
           </a:xfrm>
           <a:prstGeom prst="rect">
             <a:avLst/>
@@ -7778,14 +7371,14 @@
       </p:sp>
       <p:sp>
         <p:nvSpPr>
-          <p:cNvPr id="22" name="TextBox 21"/>
+          <p:cNvPr id="12" name="TextBox 11"/>
           <p:cNvSpPr txBox="1"/>
           <p:nvPr/>
         </p:nvSpPr>
         <p:spPr>
           <a:xfrm>
-            <a:off x="6858000" y="2871216"/>
-            <a:ext cx="4480560" cy="365760"/>
+            <a:off x="4983480" y="2871216"/>
+            <a:ext cx="6309360" cy="365760"/>
           </a:xfrm>
           <a:prstGeom prst="rect">
             <a:avLst/>
@@ -7817,14 +7410,14 @@
       </p:sp>
       <p:sp>
         <p:nvSpPr>
-          <p:cNvPr id="23" name="TextBox 22"/>
+          <p:cNvPr id="13" name="TextBox 12"/>
           <p:cNvSpPr txBox="1"/>
           <p:nvPr/>
         </p:nvSpPr>
         <p:spPr>
           <a:xfrm>
-            <a:off x="6858000" y="3300984"/>
-            <a:ext cx="4480560" cy="365760"/>
+            <a:off x="4983480" y="3300984"/>
+            <a:ext cx="6309360" cy="365760"/>
           </a:xfrm>
           <a:prstGeom prst="rect">
             <a:avLst/>
@@ -7856,14 +7449,14 @@
       </p:sp>
       <p:sp>
         <p:nvSpPr>
-          <p:cNvPr id="24" name="TextBox 23"/>
+          <p:cNvPr id="14" name="TextBox 13"/>
           <p:cNvSpPr txBox="1"/>
           <p:nvPr/>
         </p:nvSpPr>
         <p:spPr>
           <a:xfrm>
-            <a:off x="6858000" y="3730752"/>
-            <a:ext cx="4480560" cy="365760"/>
+            <a:off x="4983480" y="3730752"/>
+            <a:ext cx="6309360" cy="365760"/>
           </a:xfrm>
           <a:prstGeom prst="rect">
             <a:avLst/>
@@ -7895,14 +7488,14 @@
       </p:sp>
       <p:sp>
         <p:nvSpPr>
-          <p:cNvPr id="25" name="TextBox 24"/>
+          <p:cNvPr id="15" name="TextBox 14"/>
           <p:cNvSpPr txBox="1"/>
           <p:nvPr/>
         </p:nvSpPr>
         <p:spPr>
           <a:xfrm>
-            <a:off x="6858000" y="4160520"/>
-            <a:ext cx="4480560" cy="365760"/>
+            <a:off x="4983480" y="4160520"/>
+            <a:ext cx="6309360" cy="365760"/>
           </a:xfrm>
           <a:prstGeom prst="rect">
             <a:avLst/>
@@ -7934,14 +7527,14 @@
       </p:sp>
       <p:sp>
         <p:nvSpPr>
-          <p:cNvPr id="26" name="TextBox 25"/>
+          <p:cNvPr id="16" name="TextBox 15"/>
           <p:cNvSpPr txBox="1"/>
           <p:nvPr/>
         </p:nvSpPr>
         <p:spPr>
           <a:xfrm>
-            <a:off x="6858000" y="4590288"/>
-            <a:ext cx="4480560" cy="365760"/>
+            <a:off x="4983480" y="4590288"/>
+            <a:ext cx="6309360" cy="365760"/>
           </a:xfrm>
           <a:prstGeom prst="rect">
             <a:avLst/>
@@ -7973,14 +7566,14 @@
       </p:sp>
       <p:sp>
         <p:nvSpPr>
-          <p:cNvPr id="27" name="TextBox 26"/>
+          <p:cNvPr id="17" name="TextBox 16"/>
           <p:cNvSpPr txBox="1"/>
           <p:nvPr/>
         </p:nvSpPr>
         <p:spPr>
           <a:xfrm>
-            <a:off x="6858000" y="5020056"/>
-            <a:ext cx="4480560" cy="365760"/>
+            <a:off x="4983480" y="5020056"/>
+            <a:ext cx="6309360" cy="365760"/>
           </a:xfrm>
           <a:prstGeom prst="rect">
             <a:avLst/>
@@ -8012,14 +7605,14 @@
       </p:sp>
       <p:sp>
         <p:nvSpPr>
-          <p:cNvPr id="28" name="TextBox 27"/>
+          <p:cNvPr id="18" name="TextBox 17"/>
           <p:cNvSpPr txBox="1"/>
           <p:nvPr/>
         </p:nvSpPr>
         <p:spPr>
           <a:xfrm>
-            <a:off x="6858000" y="5449824"/>
-            <a:ext cx="4480560" cy="365760"/>
+            <a:off x="4983480" y="5449824"/>
+            <a:ext cx="6309360" cy="365760"/>
           </a:xfrm>
           <a:prstGeom prst="rect">
             <a:avLst/>
@@ -8051,14 +7644,14 @@
       </p:sp>
       <p:sp>
         <p:nvSpPr>
-          <p:cNvPr id="29" name="TextBox 28"/>
+          <p:cNvPr id="19" name="TextBox 18"/>
           <p:cNvSpPr txBox="1"/>
           <p:nvPr/>
         </p:nvSpPr>
         <p:spPr>
           <a:xfrm>
-            <a:off x="6858000" y="5879592"/>
-            <a:ext cx="4480560" cy="365760"/>
+            <a:off x="4983480" y="5879592"/>
+            <a:ext cx="6309360" cy="365760"/>
           </a:xfrm>
           <a:prstGeom prst="rect">
             <a:avLst/>
@@ -8090,7 +7683,7 @@
       </p:sp>
       <p:sp>
         <p:nvSpPr>
-          <p:cNvPr id="30" name="TextBox 29"/>
+          <p:cNvPr id="20" name="TextBox 19"/>
           <p:cNvSpPr txBox="1"/>
           <p:nvPr/>
         </p:nvSpPr>

</xml_diff>

<commit_message>
docs: fix member name 徐睿昕 -> 涂睿昕 (report & PPT)
</commit_message>
<xml_diff>
--- a/docs/斗地组_课堂展示PPT.pptx
+++ b/docs/斗地组_课堂展示PPT.pptx
@@ -1071,7 +1071,7 @@
           <a:lstStyle/>
           <a:p>
             <a:r>
-              <a:t>我们组6个人分五块任务：丁翊君负责整合和主程序，张靖悦负责地图和互动，宋若森和孙浩然负责人物敌人，徐睿昕和宋佳媛负责商店系统和测试。每个模块都有明确的代码负责人。</a:t>
+              <a:t>我们组6个人分五块任务：丁翊君负责整合和主程序，张靖悦负责地图和互动，宋若森和孙浩然负责人物敌人，涂睿昕和宋佳媛负责商店系统和测试。每个模块都有明确的代码负责人。</a:t>
             </a:r>
           </a:p>
         </p:txBody>
@@ -4423,7 +4423,7 @@
                 </a:solidFill>
                 <a:latin typeface="微软雅黑"/>
               </a:rPr>
-              <a:t>组员：丁翊君 · 张靖悦 · 宋若森 · 孙浩然 · 徐睿昕 · 宋佳媛</a:t>
+              <a:t>组员：丁翊君 · 张靖悦 · 宋若森 · 孙浩然 · 涂睿昕 · 宋佳媛</a:t>
             </a:r>
           </a:p>
         </p:txBody>
@@ -4722,7 +4722,7 @@
                 </a:solidFill>
                 <a:latin typeface="微软雅黑"/>
               </a:rPr>
-              <a:t>斗地组 · 丁翊君 张靖悦 宋若森 孙浩然 徐睿昕 宋佳媛</a:t>
+              <a:t>斗地组 · 丁翊君 张靖悦 宋若森 孙浩然 涂睿昕 宋佳媛</a:t>
             </a:r>
           </a:p>
         </p:txBody>
@@ -11525,7 +11525,7 @@
                 </a:solidFill>
                 <a:latin typeface="微软雅黑"/>
               </a:rPr>
-              <a:t>徐睿昕</a:t>
+              <a:t>涂睿昕</a:t>
             </a:r>
           </a:p>
         </p:txBody>

</xml_diff>